<commit_message>
Refocus RakshaNet on cybercrime with Claude-powered scam analysis
- Scam Check: offline rule engine for Indian frauds plus link forensics,
  upgraded by Claude structured-output analysis with rules fallback
- Scammed? golden-hour guide (1930, bank block, account recovery)
- Evidence Vault: hash-chained scam messages, file fingerprints, wallet signing
- Report: Claude-drafted cybercrime.gov.in complaint with template fallback
- Vercel functions + local dev server; remove physical-safety features
- Tests for rules, ledger and the Claude request/fallback path (mocked API)
- Refresh registration kit, README, pitch deck, screenshots and demo video

Co-Authored-By: Claude Opus 5.5 <noreply@anthropic.com>
Claude-Session: https://claude.ai/code/session_019nhhs4XLFw3KBPVWKYJMvx
</commit_message>
<xml_diff>
--- a/docs/RakshaNet-Pitch-Deck.pptx
+++ b/docs/RakshaNet-Pitch-Deck.pptx
@@ -3135,7 +3135,7 @@
         </p:nvSpPr>
         <p:spPr>
           <a:xfrm>
-            <a:off x="3474720" y="1920240"/>
+            <a:off x="3474720" y="1828800"/>
             <a:ext cx="8229600" cy="1097280"/>
           </a:xfrm>
           <a:prstGeom prst="rect">
@@ -3174,7 +3174,7 @@
         </p:nvSpPr>
         <p:spPr>
           <a:xfrm>
-            <a:off x="3474720" y="3017520"/>
+            <a:off x="3474720" y="2926080"/>
             <a:ext cx="8229600" cy="914400"/>
           </a:xfrm>
           <a:prstGeom prst="rect">
@@ -3194,13 +3194,13 @@
               </a:spcAft>
             </a:pPr>
             <a:r>
-              <a:rPr sz="2600" b="1">
+              <a:rPr sz="2800" b="1">
                 <a:solidFill>
                   <a:srgbClr val="FF3B5C"/>
                 </a:solidFill>
                 <a:latin typeface="Segoe UI"/>
               </a:rPr>
-              <a:t>Protection in seconds. Evidence nobody can quietly edit.</a:t>
+              <a:t>Your shield against cyber fraud.</a:t>
             </a:r>
           </a:p>
         </p:txBody>
@@ -3213,8 +3213,8 @@
         </p:nvSpPr>
         <p:spPr>
           <a:xfrm>
-            <a:off x="3474720" y="3931920"/>
-            <a:ext cx="8046720" cy="1097280"/>
+            <a:off x="3474720" y="3840480"/>
+            <a:ext cx="8046720" cy="1280160"/>
           </a:xfrm>
           <a:prstGeom prst="rect">
             <a:avLst/>
@@ -3239,7 +3239,7 @@
                 </a:solidFill>
                 <a:latin typeface="Segoe UI"/>
               </a:rPr>
-              <a:t>One-tap SOS, Safe Walk check-ins and a tamper-evident incident ledger you can anchor with your wallet. Async'26 Hackathon.</a:t>
+              <a:t>AI scam checker, golden-hour emergency guide, tamper-evident evidence vault and an AI complaint drafter, in one offline-first app. Async'26 Hackathon.</a:t>
             </a:r>
           </a:p>
         </p:txBody>
@@ -3343,7 +3343,7 @@
                 </a:solidFill>
                 <a:latin typeface="Segoe UI"/>
               </a:rPr>
-              <a:t>When it matters most, safety apps fail twice</a:t>
+              <a:t>Cyber fraud wins at three moments</a:t>
             </a:r>
           </a:p>
         </p:txBody>
@@ -3472,7 +3472,7 @@
                 </a:solidFill>
                 <a:latin typeface="Segoe UI"/>
               </a:rPr>
-              <a:t>Too slow to use</a:t>
+              <a:t>Before: it looks real</a:t>
             </a:r>
           </a:p>
         </p:txBody>
@@ -3485,8 +3485,8 @@
         </p:nvSpPr>
         <p:spPr>
           <a:xfrm>
-            <a:off x="914400" y="2697480"/>
-            <a:ext cx="3017520" cy="2377440"/>
+            <a:off x="914400" y="2651760"/>
+            <a:ext cx="3017520" cy="2468880"/>
           </a:xfrm>
           <a:prstGeom prst="rect">
             <a:avLst/>
@@ -3511,7 +3511,7 @@
                 </a:solidFill>
                 <a:latin typeface="Segoe UI"/>
               </a:rPr>
-              <a:t>Unlocking, finding the app, typing a message: precious seconds. One-tap buttons misfire, so people switch them off.</a:t>
+              <a:t>Fake KYC SMS, "digital arrest" calls, task scams and look-alike bank links are convincing, and people have seconds to decide.</a:t>
             </a:r>
           </a:p>
         </p:txBody>
@@ -3578,7 +3578,7 @@
             <a:avLst/>
           </a:prstGeom>
           <a:solidFill>
-            <a:srgbClr val="FF3B5C"/>
+            <a:srgbClr val="F5B301"/>
           </a:solidFill>
           <a:ln>
             <a:noFill/>
@@ -3640,7 +3640,7 @@
                 </a:solidFill>
                 <a:latin typeface="Segoe UI"/>
               </a:rPr>
-              <a:t>No one notices silence</a:t>
+              <a:t>During: panic</a:t>
             </a:r>
           </a:p>
         </p:txBody>
@@ -3653,8 +3653,8 @@
         </p:nvSpPr>
         <p:spPr>
           <a:xfrm>
-            <a:off x="4617720" y="2697480"/>
-            <a:ext cx="3017520" cy="2377440"/>
+            <a:off x="4617720" y="2651760"/>
+            <a:ext cx="3017520" cy="2468880"/>
           </a:xfrm>
           <a:prstGeom prst="rect">
             <a:avLst/>
@@ -3679,7 +3679,7 @@
                 </a:solidFill>
                 <a:latin typeface="Segoe UI"/>
               </a:rPr>
-              <a:t>Most danger is on the walk home. If you cannot press anything, nothing happens. Nobody knows you never arrived.</a:t>
+              <a:t>Victims freeze. They don't know to call 1930 within the golden hour, when the money can still be frozen.</a:t>
             </a:r>
           </a:p>
         </p:txBody>
@@ -3746,7 +3746,7 @@
             <a:avLst/>
           </a:prstGeom>
           <a:solidFill>
-            <a:srgbClr val="FF3B5C"/>
+            <a:srgbClr val="6D5DFC"/>
           </a:solidFill>
           <a:ln>
             <a:noFill/>
@@ -3808,7 +3808,7 @@
                 </a:solidFill>
                 <a:latin typeface="Segoe UI"/>
               </a:rPr>
-              <a:t>Evidence gets disputed</a:t>
+              <a:t>After: messy proof</a:t>
             </a:r>
           </a:p>
         </p:txBody>
@@ -3821,8 +3821,8 @@
         </p:nvSpPr>
         <p:spPr>
           <a:xfrm>
-            <a:off x="8321040" y="2697480"/>
-            <a:ext cx="3017520" cy="2377440"/>
+            <a:off x="8321040" y="2651760"/>
+            <a:ext cx="3017520" cy="2468880"/>
           </a:xfrm>
           <a:prstGeom prst="rect">
             <a:avLst/>
@@ -3847,7 +3847,7 @@
                 </a:solidFill>
                 <a:latin typeface="Segoe UI"/>
               </a:rPr>
-              <a:t>Screenshots and chat logs are easy to challenge: "that time was edited". Victims lose credibility after the fact.</a:t>
+              <a:t>Screenshots get deleted, complaints are vague, and evidence can be questioned. Cases stall.</a:t>
             </a:r>
           </a:p>
         </p:txBody>
@@ -3886,7 +3886,7 @@
                 </a:solidFill>
                 <a:latin typeface="Segoe UI"/>
               </a:rPr>
-              <a:t>NCRB recorded 4,45,256 cases of crimes against women in India in 2022, roughly one every 71 seconds.</a:t>
+              <a:t>India's National Cyber Crime Helpline is 1930; complaints are filed at cybercrime.gov.in. RakshaNet gets victims there faster, with better evidence.</a:t>
             </a:r>
           </a:p>
         </p:txBody>
@@ -3990,7 +3990,7 @@
                 </a:solidFill>
                 <a:latin typeface="Segoe UI"/>
               </a:rPr>
-              <a:t>Three layers of protection in one lightweight app</a:t>
+              <a:t>Check it. Act fast. Keep proof. Report.</a:t>
             </a:r>
           </a:p>
         </p:txBody>
@@ -4003,8 +4003,8 @@
         </p:nvSpPr>
         <p:spPr>
           <a:xfrm>
-            <a:off x="640080" y="1920240"/>
-            <a:ext cx="3474720" cy="3840480"/>
+            <a:off x="640080" y="1828800"/>
+            <a:ext cx="2697480" cy="4023360"/>
           </a:xfrm>
           <a:prstGeom prst="roundRect">
             <a:avLst>
@@ -4050,7 +4050,7 @@
         </p:nvSpPr>
         <p:spPr>
           <a:xfrm>
-            <a:off x="640080" y="2148840"/>
+            <a:off x="640080" y="2057400"/>
             <a:ext cx="73152" cy="457200"/>
           </a:xfrm>
           <a:prstGeom prst="rect">
@@ -4093,8 +4093,8 @@
         </p:nvSpPr>
         <p:spPr>
           <a:xfrm>
-            <a:off x="914400" y="2103120"/>
-            <a:ext cx="3017520" cy="548640"/>
+            <a:off x="914400" y="2011680"/>
+            <a:ext cx="2240280" cy="548640"/>
           </a:xfrm>
           <a:prstGeom prst="rect">
             <a:avLst/>
@@ -4119,7 +4119,7 @@
                 </a:solidFill>
                 <a:latin typeface="Segoe UI"/>
               </a:rPr>
-              <a:t>Hold-to-SOS</a:t>
+              <a:t>Scam Check</a:t>
             </a:r>
           </a:p>
         </p:txBody>
@@ -4132,8 +4132,8 @@
         </p:nvSpPr>
         <p:spPr>
           <a:xfrm>
-            <a:off x="914400" y="2697480"/>
-            <a:ext cx="3017520" cy="2926080"/>
+            <a:off x="914400" y="2560320"/>
+            <a:ext cx="2240280" cy="3200400"/>
           </a:xfrm>
           <a:prstGeom prst="rect">
             <a:avLst/>
@@ -4158,7 +4158,7 @@
                 </a:solidFill>
                 <a:latin typeface="Segoe UI"/>
               </a:rPr>
-              <a:t>Hold 1.5 s, no misfires. Captures live GPS and a note, then sends in one tap by SMS to all guardians, WhatsApp, share sheet or a 112 call.</a:t>
+              <a:t>Paste any SMS, WhatsApp, email, link or call script. Instant offline verdict, then a Claude AI analysis: risk, scam type, red flags, next steps.</a:t>
             </a:r>
           </a:p>
         </p:txBody>
@@ -4171,8 +4171,8 @@
         </p:nvSpPr>
         <p:spPr>
           <a:xfrm>
-            <a:off x="4343400" y="1920240"/>
-            <a:ext cx="3474720" cy="3840480"/>
+            <a:off x="3474720" y="1828800"/>
+            <a:ext cx="2697480" cy="4023360"/>
           </a:xfrm>
           <a:prstGeom prst="roundRect">
             <a:avLst>
@@ -4218,7 +4218,7 @@
         </p:nvSpPr>
         <p:spPr>
           <a:xfrm>
-            <a:off x="4343400" y="2148840"/>
+            <a:off x="3474720" y="2057400"/>
             <a:ext cx="73152" cy="457200"/>
           </a:xfrm>
           <a:prstGeom prst="rect">
@@ -4261,8 +4261,8 @@
         </p:nvSpPr>
         <p:spPr>
           <a:xfrm>
-            <a:off x="4617720" y="2103120"/>
-            <a:ext cx="3017520" cy="548640"/>
+            <a:off x="3749039" y="2011680"/>
+            <a:ext cx="2240280" cy="548640"/>
           </a:xfrm>
           <a:prstGeom prst="rect">
             <a:avLst/>
@@ -4287,7 +4287,7 @@
                 </a:solidFill>
                 <a:latin typeface="Segoe UI"/>
               </a:rPr>
-              <a:t>Safe Walk</a:t>
+              <a:t>Golden-hour guide</a:t>
             </a:r>
           </a:p>
         </p:txBody>
@@ -4300,8 +4300,8 @@
         </p:nvSpPr>
         <p:spPr>
           <a:xfrm>
-            <a:off x="4617720" y="2697480"/>
-            <a:ext cx="3017520" cy="2926080"/>
+            <a:off x="3749039" y="2560320"/>
+            <a:ext cx="2240280" cy="3200400"/>
           </a:xfrm>
           <a:prstGeom prst="rect">
             <a:avLst/>
@@ -4326,7 +4326,7 @@
                 </a:solidFill>
                 <a:latin typeface="Segoe UI"/>
               </a:rPr>
-              <a:t>A dead-man's switch for the trip home. Set 5 to 60 min. Tap "I'm safe" on arrival, or SOS fires automatically with your last location.</a:t>
+              <a:t>"Lost money?" flow: call 1930, block bank and UPI, secure accounts, warn contacts, with a checklist that remembers progress.</a:t>
             </a:r>
           </a:p>
         </p:txBody>
@@ -4339,8 +4339,8 @@
         </p:nvSpPr>
         <p:spPr>
           <a:xfrm>
-            <a:off x="8046720" y="1920240"/>
-            <a:ext cx="3474720" cy="3840480"/>
+            <a:off x="6309360" y="1828800"/>
+            <a:ext cx="2697480" cy="4023360"/>
           </a:xfrm>
           <a:prstGeom prst="roundRect">
             <a:avLst>
@@ -4386,7 +4386,7 @@
         </p:nvSpPr>
         <p:spPr>
           <a:xfrm>
-            <a:off x="8046720" y="2148840"/>
+            <a:off x="6309360" y="2057400"/>
             <a:ext cx="73152" cy="457200"/>
           </a:xfrm>
           <a:prstGeom prst="rect">
@@ -4429,8 +4429,8 @@
         </p:nvSpPr>
         <p:spPr>
           <a:xfrm>
-            <a:off x="8321040" y="2103120"/>
-            <a:ext cx="3017520" cy="548640"/>
+            <a:off x="6583680" y="2011680"/>
+            <a:ext cx="2240280" cy="548640"/>
           </a:xfrm>
           <a:prstGeom prst="rect">
             <a:avLst/>
@@ -4455,7 +4455,7 @@
                 </a:solidFill>
                 <a:latin typeface="Segoe UI"/>
               </a:rPr>
-              <a:t>Evidence Ledger</a:t>
+              <a:t>Evidence Vault</a:t>
             </a:r>
           </a:p>
         </p:txBody>
@@ -4468,8 +4468,8 @@
         </p:nvSpPr>
         <p:spPr>
           <a:xfrm>
-            <a:off x="8321040" y="2697480"/>
-            <a:ext cx="3017520" cy="2926080"/>
+            <a:off x="6583680" y="2560320"/>
+            <a:ext cx="2240280" cy="3200400"/>
           </a:xfrm>
           <a:prstGeom prst="rect">
             <a:avLst/>
@@ -4494,7 +4494,175 @@
                 </a:solidFill>
                 <a:latin typeface="Segoe UI"/>
               </a:rPr>
-              <a:t>Every alert and check-in is SHA-256 hashed and chained. Edit one byte and verification fails. Sign the head with your wallet to timestamp it.</a:t>
+              <a:t>Messages and screenshots are SHA-256 hashed and chained. Any edit is caught. Sign with a wallet to timestamp.</a:t>
+            </a:r>
+          </a:p>
+        </p:txBody>
+      </p:sp>
+      <p:sp>
+        <p:nvSpPr>
+          <p:cNvPr id="16" name="Rounded Rectangle 15"/>
+          <p:cNvSpPr/>
+          <p:nvPr/>
+        </p:nvSpPr>
+        <p:spPr>
+          <a:xfrm>
+            <a:off x="9144000" y="1828800"/>
+            <a:ext cx="2423160" cy="4023360"/>
+          </a:xfrm>
+          <a:prstGeom prst="roundRect">
+            <a:avLst>
+              <a:gd name="adj" fmla="val 8000"/>
+            </a:avLst>
+          </a:prstGeom>
+          <a:solidFill>
+            <a:srgbClr val="1A1E26"/>
+          </a:solidFill>
+          <a:ln>
+            <a:solidFill>
+              <a:srgbClr val="2A2F3A"/>
+            </a:solidFill>
+          </a:ln>
+        </p:spPr>
+        <p:style>
+          <a:lnRef idx="1">
+            <a:schemeClr val="accent1"/>
+          </a:lnRef>
+          <a:fillRef idx="3">
+            <a:schemeClr val="accent1"/>
+          </a:fillRef>
+          <a:effectRef idx="2">
+            <a:schemeClr val="accent1"/>
+          </a:effectRef>
+          <a:fontRef idx="minor">
+            <a:schemeClr val="lt1"/>
+          </a:fontRef>
+        </p:style>
+        <p:txBody>
+          <a:bodyPr rtlCol="0" anchor="ctr"/>
+          <a:lstStyle/>
+          <a:p>
+            <a:pPr algn="ctr"/>
+          </a:p>
+        </p:txBody>
+      </p:sp>
+      <p:sp>
+        <p:nvSpPr>
+          <p:cNvPr id="17" name="Rectangle 16"/>
+          <p:cNvSpPr/>
+          <p:nvPr/>
+        </p:nvSpPr>
+        <p:spPr>
+          <a:xfrm>
+            <a:off x="9144000" y="2057400"/>
+            <a:ext cx="73152" cy="457200"/>
+          </a:xfrm>
+          <a:prstGeom prst="rect">
+            <a:avLst/>
+          </a:prstGeom>
+          <a:solidFill>
+            <a:srgbClr val="22C55E"/>
+          </a:solidFill>
+          <a:ln>
+            <a:noFill/>
+          </a:ln>
+        </p:spPr>
+        <p:style>
+          <a:lnRef idx="1">
+            <a:schemeClr val="accent1"/>
+          </a:lnRef>
+          <a:fillRef idx="3">
+            <a:schemeClr val="accent1"/>
+          </a:fillRef>
+          <a:effectRef idx="2">
+            <a:schemeClr val="accent1"/>
+          </a:effectRef>
+          <a:fontRef idx="minor">
+            <a:schemeClr val="lt1"/>
+          </a:fontRef>
+        </p:style>
+        <p:txBody>
+          <a:bodyPr rtlCol="0" anchor="ctr"/>
+          <a:lstStyle/>
+          <a:p>
+            <a:pPr algn="ctr"/>
+          </a:p>
+        </p:txBody>
+      </p:sp>
+      <p:sp>
+        <p:nvSpPr>
+          <p:cNvPr id="18" name="TextBox 17"/>
+          <p:cNvSpPr txBox="1"/>
+          <p:nvPr/>
+        </p:nvSpPr>
+        <p:spPr>
+          <a:xfrm>
+            <a:off x="9418320" y="2011680"/>
+            <a:ext cx="1965960" cy="548640"/>
+          </a:xfrm>
+          <a:prstGeom prst="rect">
+            <a:avLst/>
+          </a:prstGeom>
+          <a:noFill/>
+        </p:spPr>
+        <p:txBody>
+          <a:bodyPr wrap="square">
+            <a:spAutoFit/>
+          </a:bodyPr>
+          <a:lstStyle/>
+          <a:p>
+            <a:pPr algn="l">
+              <a:spcAft>
+                <a:spcPts val="800"/>
+              </a:spcAft>
+            </a:pPr>
+            <a:r>
+              <a:rPr sz="2000" b="1">
+                <a:solidFill>
+                  <a:srgbClr val="EEF0F4"/>
+                </a:solidFill>
+                <a:latin typeface="Segoe UI"/>
+              </a:rPr>
+              <a:t>AI complaint</a:t>
+            </a:r>
+          </a:p>
+        </p:txBody>
+      </p:sp>
+      <p:sp>
+        <p:nvSpPr>
+          <p:cNvPr id="19" name="TextBox 18"/>
+          <p:cNvSpPr txBox="1"/>
+          <p:nvPr/>
+        </p:nvSpPr>
+        <p:spPr>
+          <a:xfrm>
+            <a:off x="9418320" y="2560320"/>
+            <a:ext cx="1965960" cy="3200400"/>
+          </a:xfrm>
+          <a:prstGeom prst="rect">
+            <a:avLst/>
+          </a:prstGeom>
+          <a:noFill/>
+        </p:spPr>
+        <p:txBody>
+          <a:bodyPr wrap="square">
+            <a:spAutoFit/>
+          </a:bodyPr>
+          <a:lstStyle/>
+          <a:p>
+            <a:pPr algn="l">
+              <a:spcAft>
+                <a:spcPts val="800"/>
+              </a:spcAft>
+            </a:pPr>
+            <a:r>
+              <a:rPr sz="1500" b="0">
+                <a:solidFill>
+                  <a:srgbClr val="9AA3B2"/>
+                </a:solidFill>
+                <a:latin typeface="Segoe UI"/>
+              </a:rPr>
+              <a:t>Claude drafts a ready-to-file cybercrime.gov.in complaint with suspect IDs and evidence hashes.</a:t>
             </a:r>
           </a:p>
         </p:txBody>
@@ -4598,7 +4766,7 @@
                 </a:solidFill>
                 <a:latin typeface="Segoe UI"/>
               </a:rPr>
-              <a:t>No backend, no sign-up, works offline</a:t>
+              <a:t>Offline-first rules plus Claude where it matters</a:t>
             </a:r>
           </a:p>
         </p:txBody>
@@ -4727,7 +4895,7 @@
                 </a:solidFill>
                 <a:latin typeface="Segoe UI"/>
               </a:rPr>
-              <a:t>1. Capture</a:t>
+              <a:t>1. Instant rules</a:t>
             </a:r>
           </a:p>
         </p:txBody>
@@ -4740,8 +4908,8 @@
         </p:nvSpPr>
         <p:spPr>
           <a:xfrm>
-            <a:off x="914400" y="2606040"/>
-            <a:ext cx="3017520" cy="1234440"/>
+            <a:off x="914400" y="2560320"/>
+            <a:ext cx="3017520" cy="1325880"/>
           </a:xfrm>
           <a:prstGeom prst="rect">
             <a:avLst/>
@@ -4760,13 +4928,13 @@
               </a:spcAft>
             </a:pPr>
             <a:r>
-              <a:rPr sz="1500" b="0">
+              <a:rPr sz="1300" b="0">
                 <a:solidFill>
                   <a:srgbClr val="9AA3B2"/>
                 </a:solidFill>
                 <a:latin typeface="Segoe UI"/>
               </a:rPr>
-              <a:t>Geolocation API (high accuracy, 8 s timeout, graceful fallback) plus an optional note.</a:t>
+              <a:t>20+ patterns for Indian scams plus link forensics: look-alike bank domains, punycode, shorteners, bare IPs, risky TLDs. Extracts UPI IDs, phones, links and amounts.</a:t>
             </a:r>
           </a:p>
         </p:txBody>
@@ -4895,7 +5063,7 @@
                 </a:solidFill>
                 <a:latin typeface="Segoe UI"/>
               </a:rPr>
-              <a:t>2. Seal</a:t>
+              <a:t>2. Claude analysis</a:t>
             </a:r>
           </a:p>
         </p:txBody>
@@ -4908,8 +5076,8 @@
         </p:nvSpPr>
         <p:spPr>
           <a:xfrm>
-            <a:off x="4617720" y="2606040"/>
-            <a:ext cx="3017520" cy="1234440"/>
+            <a:off x="4617720" y="2560320"/>
+            <a:ext cx="3017520" cy="1325880"/>
           </a:xfrm>
           <a:prstGeom prst="rect">
             <a:avLst/>
@@ -4928,13 +5096,13 @@
               </a:spcAft>
             </a:pPr>
             <a:r>
-              <a:rPr sz="1500" b="0">
+              <a:rPr sz="1300" b="0">
                 <a:solidFill>
                   <a:srgbClr val="9AA3B2"/>
                 </a:solidFill>
                 <a:latin typeface="Segoe UI"/>
               </a:rPr>
-              <a:t>Entry = {index, time, type, payload, prevHash}. Canonical JSON, then WebCrypto SHA-256. Writes are serialised so the chain never forks.</a:t>
+              <a:t>Server function calls Claude with a JSON-schema structured output. Pasted text is fenced as untrusted data. It falls back to the rules on any failure.</a:t>
             </a:r>
           </a:p>
         </p:txBody>
@@ -5063,7 +5231,7 @@
                 </a:solidFill>
                 <a:latin typeface="Segoe UI"/>
               </a:rPr>
-              <a:t>3. Alert</a:t>
+              <a:t>3. Seal</a:t>
             </a:r>
           </a:p>
         </p:txBody>
@@ -5076,8 +5244,8 @@
         </p:nvSpPr>
         <p:spPr>
           <a:xfrm>
-            <a:off x="8321040" y="2606040"/>
-            <a:ext cx="3017520" cy="1234440"/>
+            <a:off x="8321040" y="2560320"/>
+            <a:ext cx="3017520" cy="1325880"/>
           </a:xfrm>
           <a:prstGeom prst="rect">
             <a:avLst/>
@@ -5096,13 +5264,13 @@
               </a:spcAft>
             </a:pPr>
             <a:r>
-              <a:rPr sz="1500" b="0">
+              <a:rPr sz="1300" b="0">
                 <a:solidFill>
                   <a:srgbClr val="9AA3B2"/>
                 </a:solidFill>
                 <a:latin typeface="Segoe UI"/>
               </a:rPr>
-              <a:t>Prebuilt sms:, wa.me, tel:112 and Web Share links. Message carries a Maps link and the evidence hash.</a:t>
+              <a:t>Each record = canonical JSON {index, time, type, payload, prevHash} hashed with WebCrypto SHA-256. Files are hashed, never uploaded.</a:t>
             </a:r>
           </a:p>
         </p:txBody>
@@ -5231,7 +5399,7 @@
                 </a:solidFill>
                 <a:latin typeface="Segoe UI"/>
               </a:rPr>
-              <a:t>4. Verify</a:t>
+              <a:t>4. Verify &amp; anchor</a:t>
             </a:r>
           </a:p>
         </p:txBody>
@@ -5244,8 +5412,8 @@
         </p:nvSpPr>
         <p:spPr>
           <a:xfrm>
-            <a:off x="914400" y="4937759"/>
-            <a:ext cx="3017520" cy="1234440"/>
+            <a:off x="914400" y="4892040"/>
+            <a:ext cx="3017520" cy="1325880"/>
           </a:xfrm>
           <a:prstGeom prst="rect">
             <a:avLst/>
@@ -5264,13 +5432,13 @@
               </a:spcAft>
             </a:pPr>
             <a:r>
-              <a:rPr sz="1500" b="0">
+              <a:rPr sz="1300" b="0">
                 <a:solidFill>
                   <a:srgbClr val="9AA3B2"/>
                 </a:solidFill>
                 <a:latin typeface="Segoe UI"/>
               </a:rPr>
-              <a:t>Recompute every hash and link. Any edit, deletion or reorder pinpoints the exact broken record.</a:t>
+              <a:t>Recompute the chain to pinpoint any edit, deletion or reorder. EIP-1193 personal_sign timestamps the vault head.</a:t>
             </a:r>
           </a:p>
         </p:txBody>
@@ -5399,7 +5567,7 @@
                 </a:solidFill>
                 <a:latin typeface="Segoe UI"/>
               </a:rPr>
-              <a:t>5. Anchor</a:t>
+              <a:t>5. Draft</a:t>
             </a:r>
           </a:p>
         </p:txBody>
@@ -5412,8 +5580,8 @@
         </p:nvSpPr>
         <p:spPr>
           <a:xfrm>
-            <a:off x="4617720" y="4937759"/>
-            <a:ext cx="3017520" cy="1234440"/>
+            <a:off x="4617720" y="4892040"/>
+            <a:ext cx="3017520" cy="1325880"/>
           </a:xfrm>
           <a:prstGeom prst="rect">
             <a:avLst/>
@@ -5432,13 +5600,13 @@
               </a:spcAft>
             </a:pPr>
             <a:r>
-              <a:rPr sz="1500" b="0">
+              <a:rPr sz="1300" b="0">
                 <a:solidFill>
                   <a:srgbClr val="9AA3B2"/>
                 </a:solidFill>
                 <a:latin typeface="Segoe UI"/>
               </a:rPr>
-              <a:t>EIP-1193 personal_sign over the ledger head: a wallet signature proving the evidence existed at that moment.</a:t>
+              <a:t>Claude writes the complaint from the given facts only, leaving &lt;placeholders&gt; for gaps. Offline template fallback.</a:t>
             </a:r>
           </a:p>
         </p:txBody>
@@ -5567,7 +5735,7 @@
                 </a:solidFill>
                 <a:latin typeface="Segoe UI"/>
               </a:rPr>
-              <a:t>6. Find help</a:t>
+              <a:t>6. Private</a:t>
             </a:r>
           </a:p>
         </p:txBody>
@@ -5580,8 +5748,8 @@
         </p:nvSpPr>
         <p:spPr>
           <a:xfrm>
-            <a:off x="8321040" y="4937759"/>
-            <a:ext cx="3017520" cy="1234440"/>
+            <a:off x="8321040" y="4892040"/>
+            <a:ext cx="3017520" cy="1325880"/>
           </a:xfrm>
           <a:prstGeom prst="rect">
             <a:avLst/>
@@ -5600,13 +5768,13 @@
               </a:spcAft>
             </a:pPr>
             <a:r>
-              <a:rPr sz="1500" b="0">
+              <a:rPr sz="1300" b="0">
                 <a:solidFill>
                   <a:srgbClr val="9AA3B2"/>
                 </a:solidFill>
                 <a:latin typeface="Segoe UI"/>
               </a:rPr>
-              <a:t>OpenStreetMap Overpass query for police stations and hospitals within 3 km, sorted by distance.</a:t>
+              <a:t>Installable PWA with no accounts. Data stays on the device, and text is sent to AI only when you press Check or Draft.</a:t>
             </a:r>
           </a:p>
         </p:txBody>
@@ -5717,7 +5885,7 @@
       </p:sp>
       <p:pic>
         <p:nvPicPr>
-          <p:cNvPr id="4" name="Picture 3" descr="sos.png"/>
+          <p:cNvPr id="4" name="Picture 3" descr="check-result.png"/>
           <p:cNvPicPr>
             <a:picLocks noChangeAspect="1"/>
           </p:cNvPicPr>
@@ -5741,7 +5909,7 @@
       </p:pic>
       <p:pic>
         <p:nvPicPr>
-          <p:cNvPr id="5" name="Picture 4" descr="safe-walk.png"/>
+          <p:cNvPr id="5" name="Picture 4" descr="scammed.png"/>
           <p:cNvPicPr>
             <a:picLocks noChangeAspect="1"/>
           </p:cNvPicPr>
@@ -5765,7 +5933,7 @@
       </p:pic>
       <p:pic>
         <p:nvPicPr>
-          <p:cNvPr id="6" name="Picture 5" descr="sos-alert.png"/>
+          <p:cNvPr id="6" name="Picture 5" descr="vault.png"/>
           <p:cNvPicPr>
             <a:picLocks noChangeAspect="1"/>
           </p:cNvPicPr>
@@ -5789,7 +5957,7 @@
       </p:pic>
       <p:pic>
         <p:nvPicPr>
-          <p:cNvPr id="7" name="Picture 6" descr="ledger-tamper.png"/>
+          <p:cNvPr id="7" name="Picture 6" descr="report.png"/>
           <p:cNvPicPr>
             <a:picLocks noChangeAspect="1"/>
           </p:cNvPicPr>
@@ -5967,7 +6135,7 @@
         <p:spPr>
           <a:xfrm>
             <a:off x="1051560" y="1828800"/>
-            <a:ext cx="4206240" cy="548640"/>
+            <a:ext cx="4480560" cy="548640"/>
           </a:xfrm>
           <a:prstGeom prst="rect">
             <a:avLst/>
@@ -5992,7 +6160,7 @@
                 </a:solidFill>
                 <a:latin typeface="Segoe UI"/>
               </a:rPr>
-              <a:t>Misfire-proof trigger</a:t>
+              <a:t>Works with zero signal</a:t>
             </a:r>
           </a:p>
         </p:txBody>
@@ -6005,8 +6173,8 @@
         </p:nvSpPr>
         <p:spPr>
           <a:xfrm>
-            <a:off x="5303520" y="1828800"/>
-            <a:ext cx="6400800" cy="548640"/>
+            <a:off x="5577840" y="1828800"/>
+            <a:ext cx="6126480" cy="548640"/>
           </a:xfrm>
           <a:prstGeom prst="rect">
             <a:avLst/>
@@ -6031,7 +6199,7 @@
                 </a:solidFill>
                 <a:latin typeface="Segoe UI"/>
               </a:rPr>
-              <a:t>Hold-to-send with progress ring, keyboard accessible</a:t>
+              <a:t>Rule engine and vault run offline; AI enhances, never blocks</a:t>
             </a:r>
           </a:p>
         </p:txBody>
@@ -6088,7 +6256,7 @@
         <p:spPr>
           <a:xfrm>
             <a:off x="1051560" y="2560320"/>
-            <a:ext cx="4206240" cy="548640"/>
+            <a:ext cx="4480560" cy="548640"/>
           </a:xfrm>
           <a:prstGeom prst="rect">
             <a:avLst/>
@@ -6113,7 +6281,7 @@
                 </a:solidFill>
                 <a:latin typeface="Segoe UI"/>
               </a:rPr>
-              <a:t>Protects you when you cannot act</a:t>
+              <a:t>Built for Indian scams</a:t>
             </a:r>
           </a:p>
         </p:txBody>
@@ -6126,8 +6294,8 @@
         </p:nvSpPr>
         <p:spPr>
           <a:xfrm>
-            <a:off x="5303520" y="2560320"/>
-            <a:ext cx="6400800" cy="548640"/>
+            <a:off x="5577840" y="2560320"/>
+            <a:ext cx="6126480" cy="548640"/>
           </a:xfrm>
           <a:prstGeom prst="rect">
             <a:avLst/>
@@ -6152,7 +6320,7 @@
                 </a:solidFill>
                 <a:latin typeface="Segoe UI"/>
               </a:rPr>
-              <a:t>Safe Walk auto-escalates on a missed check-in</a:t>
+              <a:t>Digital arrest, UPI collect, KYC, task and loan-app frauds, plus 1930 and NCRP flow</a:t>
             </a:r>
           </a:p>
         </p:txBody>
@@ -6209,7 +6377,7 @@
         <p:spPr>
           <a:xfrm>
             <a:off x="1051560" y="3291840"/>
-            <a:ext cx="4206240" cy="548640"/>
+            <a:ext cx="4480560" cy="548640"/>
           </a:xfrm>
           <a:prstGeom prst="rect">
             <a:avLst/>
@@ -6234,7 +6402,7 @@
                 </a:solidFill>
                 <a:latin typeface="Segoe UI"/>
               </a:rPr>
-              <a:t>Court-friendly evidence</a:t>
+              <a:t>Proof that holds up</a:t>
             </a:r>
           </a:p>
         </p:txBody>
@@ -6247,8 +6415,8 @@
         </p:nvSpPr>
         <p:spPr>
           <a:xfrm>
-            <a:off x="5303520" y="3291840"/>
-            <a:ext cx="6400800" cy="548640"/>
+            <a:off x="5577840" y="3291840"/>
+            <a:ext cx="6126480" cy="548640"/>
           </a:xfrm>
           <a:prstGeom prst="rect">
             <a:avLst/>
@@ -6273,7 +6441,7 @@
                 </a:solidFill>
                 <a:latin typeface="Segoe UI"/>
               </a:rPr>
-              <a:t>Hash-chained log plus wallet signature: tampering is provable</a:t>
+              <a:t>Hash-chained vault plus wallet signature: tampering is provable</a:t>
             </a:r>
           </a:p>
         </p:txBody>
@@ -6330,7 +6498,7 @@
         <p:spPr>
           <a:xfrm>
             <a:off x="1051560" y="4023360"/>
-            <a:ext cx="4206240" cy="548640"/>
+            <a:ext cx="4480560" cy="548640"/>
           </a:xfrm>
           <a:prstGeom prst="rect">
             <a:avLst/>
@@ -6355,7 +6523,7 @@
                 </a:solidFill>
                 <a:latin typeface="Segoe UI"/>
               </a:rPr>
-              <a:t>Private by design</a:t>
+              <a:t>From panic to complaint in minutes</a:t>
             </a:r>
           </a:p>
         </p:txBody>
@@ -6368,8 +6536,8 @@
         </p:nvSpPr>
         <p:spPr>
           <a:xfrm>
-            <a:off x="5303520" y="4023360"/>
-            <a:ext cx="6400800" cy="548640"/>
+            <a:off x="5577840" y="4023360"/>
+            <a:ext cx="6126480" cy="548640"/>
           </a:xfrm>
           <a:prstGeom prst="rect">
             <a:avLst/>
@@ -6394,7 +6562,7 @@
                 </a:solidFill>
                 <a:latin typeface="Segoe UI"/>
               </a:rPr>
-              <a:t>Data stays on the device; you choose what to send and to whom</a:t>
+              <a:t>Checklist, then evidence, then an AI-drafted complaint</a:t>
             </a:r>
           </a:p>
         </p:txBody>
@@ -6451,7 +6619,7 @@
         <p:spPr>
           <a:xfrm>
             <a:off x="1051560" y="4754880"/>
-            <a:ext cx="4206240" cy="548640"/>
+            <a:ext cx="4480560" cy="548640"/>
           </a:xfrm>
           <a:prstGeom prst="rect">
             <a:avLst/>
@@ -6476,7 +6644,7 @@
                 </a:solidFill>
                 <a:latin typeface="Segoe UI"/>
               </a:rPr>
-              <a:t>Instant and offline</a:t>
+              <a:t>Safe AI by design</a:t>
             </a:r>
           </a:p>
         </p:txBody>
@@ -6489,8 +6657,8 @@
         </p:nvSpPr>
         <p:spPr>
           <a:xfrm>
-            <a:off x="5303520" y="4754880"/>
-            <a:ext cx="6400800" cy="548640"/>
+            <a:off x="5577840" y="4754880"/>
+            <a:ext cx="6126480" cy="548640"/>
           </a:xfrm>
           <a:prstGeom prst="rect">
             <a:avLst/>
@@ -6515,7 +6683,7 @@
                 </a:solidFill>
                 <a:latin typeface="Segoe UI"/>
               </a:rPr>
-              <a:t>Installable PWA, ~40 KB of app code, service-worker cached</a:t>
+              <a:t>Structured output, prompt-injection fencing, no invented facts</a:t>
             </a:r>
           </a:p>
         </p:txBody>
@@ -6572,7 +6740,7 @@
         <p:spPr>
           <a:xfrm>
             <a:off x="1051560" y="5486400"/>
-            <a:ext cx="4206240" cy="548640"/>
+            <a:ext cx="4480560" cy="548640"/>
           </a:xfrm>
           <a:prstGeom prst="rect">
             <a:avLst/>
@@ -6597,7 +6765,7 @@
                 </a:solidFill>
                 <a:latin typeface="Segoe UI"/>
               </a:rPr>
-              <a:t>Web3 without friction</a:t>
+              <a:t>Private</a:t>
             </a:r>
           </a:p>
         </p:txBody>
@@ -6610,8 +6778,8 @@
         </p:nvSpPr>
         <p:spPr>
           <a:xfrm>
-            <a:off x="5303520" y="5486400"/>
-            <a:ext cx="6400800" cy="548640"/>
+            <a:off x="5577840" y="5486400"/>
+            <a:ext cx="6126480" cy="548640"/>
           </a:xfrm>
           <a:prstGeom prst="rect">
             <a:avLst/>
@@ -6636,7 +6804,7 @@
                 </a:solidFill>
                 <a:latin typeface="Segoe UI"/>
               </a:rPr>
-              <a:t>Any EVM wallet signs; no gas, no token needed to stay safe</a:t>
+              <a:t>No sign-up, no database; you choose what is sent</a:t>
             </a:r>
           </a:p>
         </p:txBody>
@@ -6740,7 +6908,7 @@
                 </a:solidFill>
                 <a:latin typeface="Segoe UI"/>
               </a:rPr>
-              <a:t>From prototype to a community safety network</a:t>
+              <a:t>From prototype to a national scam shield</a:t>
             </a:r>
           </a:p>
         </p:txBody>
@@ -6882,8 +7050,8 @@
         </p:nvSpPr>
         <p:spPr>
           <a:xfrm>
-            <a:off x="914400" y="2697480"/>
-            <a:ext cx="3017520" cy="2560320"/>
+            <a:off x="914400" y="2651760"/>
+            <a:ext cx="3017520" cy="2651760"/>
           </a:xfrm>
           <a:prstGeom prst="rect">
             <a:avLst/>
@@ -6908,7 +7076,7 @@
                 </a:solidFill>
                 <a:latin typeface="Segoe UI"/>
               </a:rPr>
-              <a:t>Hold-to-SOS, Safe Walk, hash-chained ledger, wallet signing, nearby help map, offline PWA.</a:t>
+              <a:t>Offline rules plus Claude scam analysis, golden-hour guide, hash-chained Evidence Vault with wallet signing, AI complaint drafter, PWA.</a:t>
             </a:r>
           </a:p>
         </p:txBody>
@@ -7050,8 +7218,8 @@
         </p:nvSpPr>
         <p:spPr>
           <a:xfrm>
-            <a:off x="4617720" y="2697480"/>
-            <a:ext cx="3017520" cy="2560320"/>
+            <a:off x="4617720" y="2651760"/>
+            <a:ext cx="3017520" cy="2651760"/>
           </a:xfrm>
           <a:prstGeom prst="rect">
             <a:avLst/>
@@ -7076,7 +7244,7 @@
                 </a:solidFill>
                 <a:latin typeface="Segoe UI"/>
               </a:rPr>
-              <a:t>On-chain anchoring: periodic Merkle root of ledgers to a low-fee chain. Background SMS gateway. Shake / power-button trigger.</a:t>
+              <a:t>Screenshot input to Claude, Hindi and regional languages, WhatsApp bot and browser extension, community-reported scam numbers and UPI IDs.</a:t>
             </a:r>
           </a:p>
         </p:txBody>
@@ -7218,8 +7386,8 @@
         </p:nvSpPr>
         <p:spPr>
           <a:xfrm>
-            <a:off x="8321040" y="2697480"/>
-            <a:ext cx="3017520" cy="2560320"/>
+            <a:off x="8321040" y="2651760"/>
+            <a:ext cx="3017520" cy="2651760"/>
           </a:xfrm>
           <a:prstGeom prst="rect">
             <a:avLst/>
@@ -7244,7 +7412,7 @@
                 </a:solidFill>
                 <a:latin typeface="Segoe UI"/>
               </a:rPr>
-              <a:t>Verified responder network with reputation, hashed audio/photo evidence, NGO and police dashboard, multilingual voice SOS.</a:t>
+              <a:t>Periodic on-chain anchoring of vault roots, bank and NCRP integrations, live call-scam detection, dashboard for police cyber cells.</a:t>
             </a:r>
           </a:p>
         </p:txBody>
@@ -7327,13 +7495,13 @@
               </a:spcAft>
             </a:pPr>
             <a:r>
-              <a:rPr sz="3000" b="1">
+              <a:rPr sz="3200" b="1">
                 <a:solidFill>
                   <a:srgbClr val="EEF0F4"/>
                 </a:solidFill>
                 <a:latin typeface="Segoe UI"/>
               </a:rPr>
-              <a:t>Safety should take one gesture, and the truth should be provable.</a:t>
+              <a:t>Stop the scam. Save the proof. Get help faster.</a:t>
             </a:r>
           </a:p>
         </p:txBody>
@@ -7388,7 +7556,7 @@
                 </a:solidFill>
                 <a:latin typeface="Segoe UI"/>
               </a:rPr>
-              <a:t>Thank you</a:t>
+              <a:t>Helpline 1930  ·  cybercrime.gov.in</a:t>
             </a:r>
           </a:p>
         </p:txBody>

</xml_diff>

<commit_message>
Add free Gemini support alongside Claude
- lib/assistant.js picks Claude (ANTHROPIC_API_KEY), else Gemini
  (GEMINI_API_KEY, gemini-flash-latest via @google/genai), else offline rules
- Same JSON-schema structured output and fallbacks for blocked/truncated answers
- UI labels which AI answered; dev server logs the active provider
- Gemini tests against a mocked API; docs, deck and demo captions updated

Co-Authored-By: Claude Opus 5.5 <noreply@anthropic.com>
Claude-Session: https://claude.ai/code/session_019nhhs4XLFw3KBPVWKYJMvx
</commit_message>
<xml_diff>
--- a/docs/RakshaNet-Pitch-Deck.pptx
+++ b/docs/RakshaNet-Pitch-Deck.pptx
@@ -4158,7 +4158,7 @@
                 </a:solidFill>
                 <a:latin typeface="Segoe UI"/>
               </a:rPr>
-              <a:t>Paste any SMS, WhatsApp, email, link or call script. Instant offline verdict, then a Claude AI analysis: risk, scam type, red flags, next steps.</a:t>
+              <a:t>Paste any SMS, WhatsApp, email, link or call script. Instant offline verdict, then an AI analysis (Gemini or Claude): risk, scam type, red flags, next steps.</a:t>
             </a:r>
           </a:p>
         </p:txBody>
@@ -4662,7 +4662,7 @@
                 </a:solidFill>
                 <a:latin typeface="Segoe UI"/>
               </a:rPr>
-              <a:t>Claude drafts a ready-to-file cybercrime.gov.in complaint with suspect IDs and evidence hashes.</a:t>
+              <a:t>AI drafts a ready-to-file cybercrime.gov.in complaint with suspect IDs and evidence hashes.</a:t>
             </a:r>
           </a:p>
         </p:txBody>
@@ -4766,7 +4766,7 @@
                 </a:solidFill>
                 <a:latin typeface="Segoe UI"/>
               </a:rPr>
-              <a:t>Offline-first rules plus Claude where it matters</a:t>
+              <a:t>Offline-first rules plus AI where it matters</a:t>
             </a:r>
           </a:p>
         </p:txBody>
@@ -5063,7 +5063,7 @@
                 </a:solidFill>
                 <a:latin typeface="Segoe UI"/>
               </a:rPr>
-              <a:t>2. Claude analysis</a:t>
+              <a:t>2. AI analysis</a:t>
             </a:r>
           </a:p>
         </p:txBody>
@@ -5102,7 +5102,7 @@
                 </a:solidFill>
                 <a:latin typeface="Segoe UI"/>
               </a:rPr>
-              <a:t>Server function calls Claude with a JSON-schema structured output. Pasted text is fenced as untrusted data. It falls back to the rules on any failure.</a:t>
+              <a:t>Server function calls Gemini (free tier) or Claude with a JSON-schema structured output. Pasted text is fenced as untrusted data. It falls back to the rules on any failure.</a:t>
             </a:r>
           </a:p>
         </p:txBody>
@@ -5606,7 +5606,7 @@
                 </a:solidFill>
                 <a:latin typeface="Segoe UI"/>
               </a:rPr>
-              <a:t>Claude writes the complaint from the given facts only, leaving &lt;placeholders&gt; for gaps. Offline template fallback.</a:t>
+              <a:t>The AI writes the complaint from the given facts only, leaving &lt;placeholders&gt; for gaps. Offline template fallback.</a:t>
             </a:r>
           </a:p>
         </p:txBody>
@@ -7076,7 +7076,7 @@
                 </a:solidFill>
                 <a:latin typeface="Segoe UI"/>
               </a:rPr>
-              <a:t>Offline rules plus Claude scam analysis, golden-hour guide, hash-chained Evidence Vault with wallet signing, AI complaint drafter, PWA.</a:t>
+              <a:t>Offline rules plus AI scam analysis (Gemini / Claude), golden-hour guide, hash-chained Evidence Vault with wallet signing, AI complaint drafter, PWA.</a:t>
             </a:r>
           </a:p>
         </p:txBody>
@@ -7244,7 +7244,7 @@
                 </a:solidFill>
                 <a:latin typeface="Segoe UI"/>
               </a:rPr>
-              <a:t>Screenshot input to Claude, Hindi and regional languages, WhatsApp bot and browser extension, community-reported scam numbers and UPI IDs.</a:t>
+              <a:t>Screenshot input to the AI, Hindi and regional languages, WhatsApp bot and browser extension, community-reported scam numbers and UPI IDs.</a:t>
             </a:r>
           </a:p>
         </p:txBody>

</xml_diff>

<commit_message>
Polish risk meter and refresh media in the blue style
- Readout moved below the dial so it no longer overlaps the needle pivot
- High band eases toward 99 instead of pinning every scam at 100;
  safe results show a small green arc, no stray end cap
- Blue logo PNGs, screenshots, pitch deck and demo video regenerated

Co-Authored-By: Claude Opus 5.5 <noreply@anthropic.com>
Claude-Session: https://claude.ai/code/session_019nhhs4XLFw3KBPVWKYJMvx
</commit_message>
<xml_diff>
--- a/docs/RakshaNet-Pitch-Deck.pptx
+++ b/docs/RakshaNet-Pitch-Deck.pptx
@@ -3091,7 +3091,7 @@
     <p:bg>
       <p:bgPr>
         <a:solidFill>
-          <a:srgbClr val="0F1115"/>
+          <a:srgbClr val="060A1A"/>
         </a:solidFill>
         <a:effectLst/>
       </p:bgPr>
@@ -3157,7 +3157,7 @@
             <a:r>
               <a:rPr sz="6000" b="1">
                 <a:solidFill>
-                  <a:srgbClr val="EEF0F4"/>
+                  <a:srgbClr val="EAF1FF"/>
                 </a:solidFill>
                 <a:latin typeface="Segoe UI"/>
               </a:rPr>
@@ -3196,7 +3196,7 @@
             <a:r>
               <a:rPr sz="2800" b="1">
                 <a:solidFill>
-                  <a:srgbClr val="FF3B5C"/>
+                  <a:srgbClr val="3B82F6"/>
                 </a:solidFill>
                 <a:latin typeface="Segoe UI"/>
               </a:rPr>
@@ -3235,7 +3235,7 @@
             <a:r>
               <a:rPr sz="1800" b="0">
                 <a:solidFill>
-                  <a:srgbClr val="9AA3B2"/>
+                  <a:srgbClr val="98A8D4"/>
                 </a:solidFill>
                 <a:latin typeface="Segoe UI"/>
               </a:rPr>
@@ -3258,7 +3258,7 @@
     <p:bg>
       <p:bgPr>
         <a:solidFill>
-          <a:srgbClr val="0F1115"/>
+          <a:srgbClr val="060A1A"/>
         </a:solidFill>
         <a:effectLst/>
       </p:bgPr>
@@ -3300,7 +3300,7 @@
             <a:r>
               <a:rPr sz="1300" b="1">
                 <a:solidFill>
-                  <a:srgbClr val="FF3B5C"/>
+                  <a:srgbClr val="3B82F6"/>
                 </a:solidFill>
                 <a:latin typeface="Segoe UI"/>
               </a:rPr>
@@ -3339,7 +3339,7 @@
             <a:r>
               <a:rPr sz="3400" b="1">
                 <a:solidFill>
-                  <a:srgbClr val="EEF0F4"/>
+                  <a:srgbClr val="EAF1FF"/>
                 </a:solidFill>
                 <a:latin typeface="Segoe UI"/>
               </a:rPr>
@@ -3365,11 +3365,11 @@
             </a:avLst>
           </a:prstGeom>
           <a:solidFill>
-            <a:srgbClr val="1A1E26"/>
+            <a:srgbClr val="111A3D"/>
           </a:solidFill>
           <a:ln>
             <a:solidFill>
-              <a:srgbClr val="2A2F3A"/>
+              <a:srgbClr val="243472"/>
             </a:solidFill>
           </a:ln>
         </p:spPr>
@@ -3410,7 +3410,7 @@
             <a:avLst/>
           </a:prstGeom>
           <a:solidFill>
-            <a:srgbClr val="FF3B5C"/>
+            <a:srgbClr val="3B82F6"/>
           </a:solidFill>
           <a:ln>
             <a:noFill/>
@@ -3468,7 +3468,7 @@
             <a:r>
               <a:rPr sz="2000" b="1">
                 <a:solidFill>
-                  <a:srgbClr val="EEF0F4"/>
+                  <a:srgbClr val="EAF1FF"/>
                 </a:solidFill>
                 <a:latin typeface="Segoe UI"/>
               </a:rPr>
@@ -3507,7 +3507,7 @@
             <a:r>
               <a:rPr sz="1500" b="0">
                 <a:solidFill>
-                  <a:srgbClr val="9AA3B2"/>
+                  <a:srgbClr val="98A8D4"/>
                 </a:solidFill>
                 <a:latin typeface="Segoe UI"/>
               </a:rPr>
@@ -3533,11 +3533,11 @@
             </a:avLst>
           </a:prstGeom>
           <a:solidFill>
-            <a:srgbClr val="1A1E26"/>
+            <a:srgbClr val="111A3D"/>
           </a:solidFill>
           <a:ln>
             <a:solidFill>
-              <a:srgbClr val="2A2F3A"/>
+              <a:srgbClr val="243472"/>
             </a:solidFill>
           </a:ln>
         </p:spPr>
@@ -3636,7 +3636,7 @@
             <a:r>
               <a:rPr sz="2000" b="1">
                 <a:solidFill>
-                  <a:srgbClr val="EEF0F4"/>
+                  <a:srgbClr val="EAF1FF"/>
                 </a:solidFill>
                 <a:latin typeface="Segoe UI"/>
               </a:rPr>
@@ -3675,7 +3675,7 @@
             <a:r>
               <a:rPr sz="1500" b="0">
                 <a:solidFill>
-                  <a:srgbClr val="9AA3B2"/>
+                  <a:srgbClr val="98A8D4"/>
                 </a:solidFill>
                 <a:latin typeface="Segoe UI"/>
               </a:rPr>
@@ -3701,11 +3701,11 @@
             </a:avLst>
           </a:prstGeom>
           <a:solidFill>
-            <a:srgbClr val="1A1E26"/>
+            <a:srgbClr val="111A3D"/>
           </a:solidFill>
           <a:ln>
             <a:solidFill>
-              <a:srgbClr val="2A2F3A"/>
+              <a:srgbClr val="243472"/>
             </a:solidFill>
           </a:ln>
         </p:spPr>
@@ -3804,7 +3804,7 @@
             <a:r>
               <a:rPr sz="2000" b="1">
                 <a:solidFill>
-                  <a:srgbClr val="EEF0F4"/>
+                  <a:srgbClr val="EAF1FF"/>
                 </a:solidFill>
                 <a:latin typeface="Segoe UI"/>
               </a:rPr>
@@ -3843,7 +3843,7 @@
             <a:r>
               <a:rPr sz="1500" b="0">
                 <a:solidFill>
-                  <a:srgbClr val="9AA3B2"/>
+                  <a:srgbClr val="98A8D4"/>
                 </a:solidFill>
                 <a:latin typeface="Segoe UI"/>
               </a:rPr>
@@ -3882,7 +3882,7 @@
             <a:r>
               <a:rPr sz="1600" b="0">
                 <a:solidFill>
-                  <a:srgbClr val="9AA3B2"/>
+                  <a:srgbClr val="98A8D4"/>
                 </a:solidFill>
                 <a:latin typeface="Segoe UI"/>
               </a:rPr>
@@ -3905,7 +3905,7 @@
     <p:bg>
       <p:bgPr>
         <a:solidFill>
-          <a:srgbClr val="0F1115"/>
+          <a:srgbClr val="060A1A"/>
         </a:solidFill>
         <a:effectLst/>
       </p:bgPr>
@@ -3947,7 +3947,7 @@
             <a:r>
               <a:rPr sz="1300" b="1">
                 <a:solidFill>
-                  <a:srgbClr val="FF3B5C"/>
+                  <a:srgbClr val="3B82F6"/>
                 </a:solidFill>
                 <a:latin typeface="Segoe UI"/>
               </a:rPr>
@@ -3986,7 +3986,7 @@
             <a:r>
               <a:rPr sz="3400" b="1">
                 <a:solidFill>
-                  <a:srgbClr val="EEF0F4"/>
+                  <a:srgbClr val="EAF1FF"/>
                 </a:solidFill>
                 <a:latin typeface="Segoe UI"/>
               </a:rPr>
@@ -4012,11 +4012,11 @@
             </a:avLst>
           </a:prstGeom>
           <a:solidFill>
-            <a:srgbClr val="1A1E26"/>
+            <a:srgbClr val="111A3D"/>
           </a:solidFill>
           <a:ln>
             <a:solidFill>
-              <a:srgbClr val="2A2F3A"/>
+              <a:srgbClr val="243472"/>
             </a:solidFill>
           </a:ln>
         </p:spPr>
@@ -4057,7 +4057,7 @@
             <a:avLst/>
           </a:prstGeom>
           <a:solidFill>
-            <a:srgbClr val="FF3B5C"/>
+            <a:srgbClr val="3B82F6"/>
           </a:solidFill>
           <a:ln>
             <a:noFill/>
@@ -4115,7 +4115,7 @@
             <a:r>
               <a:rPr sz="2000" b="1">
                 <a:solidFill>
-                  <a:srgbClr val="EEF0F4"/>
+                  <a:srgbClr val="EAF1FF"/>
                 </a:solidFill>
                 <a:latin typeface="Segoe UI"/>
               </a:rPr>
@@ -4154,7 +4154,7 @@
             <a:r>
               <a:rPr sz="1500" b="0">
                 <a:solidFill>
-                  <a:srgbClr val="9AA3B2"/>
+                  <a:srgbClr val="98A8D4"/>
                 </a:solidFill>
                 <a:latin typeface="Segoe UI"/>
               </a:rPr>
@@ -4180,11 +4180,11 @@
             </a:avLst>
           </a:prstGeom>
           <a:solidFill>
-            <a:srgbClr val="1A1E26"/>
+            <a:srgbClr val="111A3D"/>
           </a:solidFill>
           <a:ln>
             <a:solidFill>
-              <a:srgbClr val="2A2F3A"/>
+              <a:srgbClr val="243472"/>
             </a:solidFill>
           </a:ln>
         </p:spPr>
@@ -4283,7 +4283,7 @@
             <a:r>
               <a:rPr sz="2000" b="1">
                 <a:solidFill>
-                  <a:srgbClr val="EEF0F4"/>
+                  <a:srgbClr val="EAF1FF"/>
                 </a:solidFill>
                 <a:latin typeface="Segoe UI"/>
               </a:rPr>
@@ -4322,7 +4322,7 @@
             <a:r>
               <a:rPr sz="1500" b="0">
                 <a:solidFill>
-                  <a:srgbClr val="9AA3B2"/>
+                  <a:srgbClr val="98A8D4"/>
                 </a:solidFill>
                 <a:latin typeface="Segoe UI"/>
               </a:rPr>
@@ -4348,11 +4348,11 @@
             </a:avLst>
           </a:prstGeom>
           <a:solidFill>
-            <a:srgbClr val="1A1E26"/>
+            <a:srgbClr val="111A3D"/>
           </a:solidFill>
           <a:ln>
             <a:solidFill>
-              <a:srgbClr val="2A2F3A"/>
+              <a:srgbClr val="243472"/>
             </a:solidFill>
           </a:ln>
         </p:spPr>
@@ -4451,7 +4451,7 @@
             <a:r>
               <a:rPr sz="2000" b="1">
                 <a:solidFill>
-                  <a:srgbClr val="EEF0F4"/>
+                  <a:srgbClr val="EAF1FF"/>
                 </a:solidFill>
                 <a:latin typeface="Segoe UI"/>
               </a:rPr>
@@ -4490,7 +4490,7 @@
             <a:r>
               <a:rPr sz="1500" b="0">
                 <a:solidFill>
-                  <a:srgbClr val="9AA3B2"/>
+                  <a:srgbClr val="98A8D4"/>
                 </a:solidFill>
                 <a:latin typeface="Segoe UI"/>
               </a:rPr>
@@ -4516,11 +4516,11 @@
             </a:avLst>
           </a:prstGeom>
           <a:solidFill>
-            <a:srgbClr val="1A1E26"/>
+            <a:srgbClr val="111A3D"/>
           </a:solidFill>
           <a:ln>
             <a:solidFill>
-              <a:srgbClr val="2A2F3A"/>
+              <a:srgbClr val="243472"/>
             </a:solidFill>
           </a:ln>
         </p:spPr>
@@ -4619,7 +4619,7 @@
             <a:r>
               <a:rPr sz="2000" b="1">
                 <a:solidFill>
-                  <a:srgbClr val="EEF0F4"/>
+                  <a:srgbClr val="EAF1FF"/>
                 </a:solidFill>
                 <a:latin typeface="Segoe UI"/>
               </a:rPr>
@@ -4658,7 +4658,7 @@
             <a:r>
               <a:rPr sz="1500" b="0">
                 <a:solidFill>
-                  <a:srgbClr val="9AA3B2"/>
+                  <a:srgbClr val="98A8D4"/>
                 </a:solidFill>
                 <a:latin typeface="Segoe UI"/>
               </a:rPr>
@@ -4681,7 +4681,7 @@
     <p:bg>
       <p:bgPr>
         <a:solidFill>
-          <a:srgbClr val="0F1115"/>
+          <a:srgbClr val="060A1A"/>
         </a:solidFill>
         <a:effectLst/>
       </p:bgPr>
@@ -4723,7 +4723,7 @@
             <a:r>
               <a:rPr sz="1300" b="1">
                 <a:solidFill>
-                  <a:srgbClr val="FF3B5C"/>
+                  <a:srgbClr val="3B82F6"/>
                 </a:solidFill>
                 <a:latin typeface="Segoe UI"/>
               </a:rPr>
@@ -4762,7 +4762,7 @@
             <a:r>
               <a:rPr sz="3400" b="1">
                 <a:solidFill>
-                  <a:srgbClr val="EEF0F4"/>
+                  <a:srgbClr val="EAF1FF"/>
                 </a:solidFill>
                 <a:latin typeface="Segoe UI"/>
               </a:rPr>
@@ -4788,11 +4788,11 @@
             </a:avLst>
           </a:prstGeom>
           <a:solidFill>
-            <a:srgbClr val="1A1E26"/>
+            <a:srgbClr val="111A3D"/>
           </a:solidFill>
           <a:ln>
             <a:solidFill>
-              <a:srgbClr val="2A2F3A"/>
+              <a:srgbClr val="243472"/>
             </a:solidFill>
           </a:ln>
         </p:spPr>
@@ -4833,7 +4833,7 @@
             <a:avLst/>
           </a:prstGeom>
           <a:solidFill>
-            <a:srgbClr val="FF3B5C"/>
+            <a:srgbClr val="3B82F6"/>
           </a:solidFill>
           <a:ln>
             <a:noFill/>
@@ -4891,7 +4891,7 @@
             <a:r>
               <a:rPr sz="2000" b="1">
                 <a:solidFill>
-                  <a:srgbClr val="EEF0F4"/>
+                  <a:srgbClr val="EAF1FF"/>
                 </a:solidFill>
                 <a:latin typeface="Segoe UI"/>
               </a:rPr>
@@ -4930,7 +4930,7 @@
             <a:r>
               <a:rPr sz="1300" b="0">
                 <a:solidFill>
-                  <a:srgbClr val="9AA3B2"/>
+                  <a:srgbClr val="98A8D4"/>
                 </a:solidFill>
                 <a:latin typeface="Segoe UI"/>
               </a:rPr>
@@ -4956,11 +4956,11 @@
             </a:avLst>
           </a:prstGeom>
           <a:solidFill>
-            <a:srgbClr val="1A1E26"/>
+            <a:srgbClr val="111A3D"/>
           </a:solidFill>
           <a:ln>
             <a:solidFill>
-              <a:srgbClr val="2A2F3A"/>
+              <a:srgbClr val="243472"/>
             </a:solidFill>
           </a:ln>
         </p:spPr>
@@ -5001,7 +5001,7 @@
             <a:avLst/>
           </a:prstGeom>
           <a:solidFill>
-            <a:srgbClr val="FF3B5C"/>
+            <a:srgbClr val="3B82F6"/>
           </a:solidFill>
           <a:ln>
             <a:noFill/>
@@ -5059,7 +5059,7 @@
             <a:r>
               <a:rPr sz="2000" b="1">
                 <a:solidFill>
-                  <a:srgbClr val="EEF0F4"/>
+                  <a:srgbClr val="EAF1FF"/>
                 </a:solidFill>
                 <a:latin typeface="Segoe UI"/>
               </a:rPr>
@@ -5098,7 +5098,7 @@
             <a:r>
               <a:rPr sz="1300" b="0">
                 <a:solidFill>
-                  <a:srgbClr val="9AA3B2"/>
+                  <a:srgbClr val="98A8D4"/>
                 </a:solidFill>
                 <a:latin typeface="Segoe UI"/>
               </a:rPr>
@@ -5124,11 +5124,11 @@
             </a:avLst>
           </a:prstGeom>
           <a:solidFill>
-            <a:srgbClr val="1A1E26"/>
+            <a:srgbClr val="111A3D"/>
           </a:solidFill>
           <a:ln>
             <a:solidFill>
-              <a:srgbClr val="2A2F3A"/>
+              <a:srgbClr val="243472"/>
             </a:solidFill>
           </a:ln>
         </p:spPr>
@@ -5169,7 +5169,7 @@
             <a:avLst/>
           </a:prstGeom>
           <a:solidFill>
-            <a:srgbClr val="FF3B5C"/>
+            <a:srgbClr val="3B82F6"/>
           </a:solidFill>
           <a:ln>
             <a:noFill/>
@@ -5227,7 +5227,7 @@
             <a:r>
               <a:rPr sz="2000" b="1">
                 <a:solidFill>
-                  <a:srgbClr val="EEF0F4"/>
+                  <a:srgbClr val="EAF1FF"/>
                 </a:solidFill>
                 <a:latin typeface="Segoe UI"/>
               </a:rPr>
@@ -5266,7 +5266,7 @@
             <a:r>
               <a:rPr sz="1300" b="0">
                 <a:solidFill>
-                  <a:srgbClr val="9AA3B2"/>
+                  <a:srgbClr val="98A8D4"/>
                 </a:solidFill>
                 <a:latin typeface="Segoe UI"/>
               </a:rPr>
@@ -5292,11 +5292,11 @@
             </a:avLst>
           </a:prstGeom>
           <a:solidFill>
-            <a:srgbClr val="1A1E26"/>
+            <a:srgbClr val="111A3D"/>
           </a:solidFill>
           <a:ln>
             <a:solidFill>
-              <a:srgbClr val="2A2F3A"/>
+              <a:srgbClr val="243472"/>
             </a:solidFill>
           </a:ln>
         </p:spPr>
@@ -5337,7 +5337,7 @@
             <a:avLst/>
           </a:prstGeom>
           <a:solidFill>
-            <a:srgbClr val="FF3B5C"/>
+            <a:srgbClr val="3B82F6"/>
           </a:solidFill>
           <a:ln>
             <a:noFill/>
@@ -5395,7 +5395,7 @@
             <a:r>
               <a:rPr sz="2000" b="1">
                 <a:solidFill>
-                  <a:srgbClr val="EEF0F4"/>
+                  <a:srgbClr val="EAF1FF"/>
                 </a:solidFill>
                 <a:latin typeface="Segoe UI"/>
               </a:rPr>
@@ -5434,7 +5434,7 @@
             <a:r>
               <a:rPr sz="1300" b="0">
                 <a:solidFill>
-                  <a:srgbClr val="9AA3B2"/>
+                  <a:srgbClr val="98A8D4"/>
                 </a:solidFill>
                 <a:latin typeface="Segoe UI"/>
               </a:rPr>
@@ -5460,11 +5460,11 @@
             </a:avLst>
           </a:prstGeom>
           <a:solidFill>
-            <a:srgbClr val="1A1E26"/>
+            <a:srgbClr val="111A3D"/>
           </a:solidFill>
           <a:ln>
             <a:solidFill>
-              <a:srgbClr val="2A2F3A"/>
+              <a:srgbClr val="243472"/>
             </a:solidFill>
           </a:ln>
         </p:spPr>
@@ -5505,7 +5505,7 @@
             <a:avLst/>
           </a:prstGeom>
           <a:solidFill>
-            <a:srgbClr val="FF3B5C"/>
+            <a:srgbClr val="3B82F6"/>
           </a:solidFill>
           <a:ln>
             <a:noFill/>
@@ -5563,7 +5563,7 @@
             <a:r>
               <a:rPr sz="2000" b="1">
                 <a:solidFill>
-                  <a:srgbClr val="EEF0F4"/>
+                  <a:srgbClr val="EAF1FF"/>
                 </a:solidFill>
                 <a:latin typeface="Segoe UI"/>
               </a:rPr>
@@ -5602,7 +5602,7 @@
             <a:r>
               <a:rPr sz="1300" b="0">
                 <a:solidFill>
-                  <a:srgbClr val="9AA3B2"/>
+                  <a:srgbClr val="98A8D4"/>
                 </a:solidFill>
                 <a:latin typeface="Segoe UI"/>
               </a:rPr>
@@ -5628,11 +5628,11 @@
             </a:avLst>
           </a:prstGeom>
           <a:solidFill>
-            <a:srgbClr val="1A1E26"/>
+            <a:srgbClr val="111A3D"/>
           </a:solidFill>
           <a:ln>
             <a:solidFill>
-              <a:srgbClr val="2A2F3A"/>
+              <a:srgbClr val="243472"/>
             </a:solidFill>
           </a:ln>
         </p:spPr>
@@ -5673,7 +5673,7 @@
             <a:avLst/>
           </a:prstGeom>
           <a:solidFill>
-            <a:srgbClr val="FF3B5C"/>
+            <a:srgbClr val="3B82F6"/>
           </a:solidFill>
           <a:ln>
             <a:noFill/>
@@ -5731,7 +5731,7 @@
             <a:r>
               <a:rPr sz="2000" b="1">
                 <a:solidFill>
-                  <a:srgbClr val="EEF0F4"/>
+                  <a:srgbClr val="EAF1FF"/>
                 </a:solidFill>
                 <a:latin typeface="Segoe UI"/>
               </a:rPr>
@@ -5770,7 +5770,7 @@
             <a:r>
               <a:rPr sz="1300" b="0">
                 <a:solidFill>
-                  <a:srgbClr val="9AA3B2"/>
+                  <a:srgbClr val="98A8D4"/>
                 </a:solidFill>
                 <a:latin typeface="Segoe UI"/>
               </a:rPr>
@@ -5793,7 +5793,7 @@
     <p:bg>
       <p:bgPr>
         <a:solidFill>
-          <a:srgbClr val="0F1115"/>
+          <a:srgbClr val="060A1A"/>
         </a:solidFill>
         <a:effectLst/>
       </p:bgPr>
@@ -5835,7 +5835,7 @@
             <a:r>
               <a:rPr sz="1300" b="1">
                 <a:solidFill>
-                  <a:srgbClr val="FF3B5C"/>
+                  <a:srgbClr val="3B82F6"/>
                 </a:solidFill>
                 <a:latin typeface="Segoe UI"/>
               </a:rPr>
@@ -5874,7 +5874,7 @@
             <a:r>
               <a:rPr sz="3400" b="1">
                 <a:solidFill>
-                  <a:srgbClr val="EEF0F4"/>
+                  <a:srgbClr val="EAF1FF"/>
                 </a:solidFill>
                 <a:latin typeface="Segoe UI"/>
               </a:rPr>
@@ -5993,7 +5993,7 @@
     <p:bg>
       <p:bgPr>
         <a:solidFill>
-          <a:srgbClr val="0F1115"/>
+          <a:srgbClr val="060A1A"/>
         </a:solidFill>
         <a:effectLst/>
       </p:bgPr>
@@ -6035,7 +6035,7 @@
             <a:r>
               <a:rPr sz="1300" b="1">
                 <a:solidFill>
-                  <a:srgbClr val="FF3B5C"/>
+                  <a:srgbClr val="3B82F6"/>
                 </a:solidFill>
                 <a:latin typeface="Segoe UI"/>
               </a:rPr>
@@ -6074,7 +6074,7 @@
             <a:r>
               <a:rPr sz="3400" b="1">
                 <a:solidFill>
-                  <a:srgbClr val="EEF0F4"/>
+                  <a:srgbClr val="EAF1FF"/>
                 </a:solidFill>
                 <a:latin typeface="Segoe UI"/>
               </a:rPr>
@@ -6156,7 +6156,7 @@
             <a:r>
               <a:rPr sz="1900" b="1">
                 <a:solidFill>
-                  <a:srgbClr val="EEF0F4"/>
+                  <a:srgbClr val="EAF1FF"/>
                 </a:solidFill>
                 <a:latin typeface="Segoe UI"/>
               </a:rPr>
@@ -6195,7 +6195,7 @@
             <a:r>
               <a:rPr sz="1700" b="0">
                 <a:solidFill>
-                  <a:srgbClr val="9AA3B2"/>
+                  <a:srgbClr val="98A8D4"/>
                 </a:solidFill>
                 <a:latin typeface="Segoe UI"/>
               </a:rPr>
@@ -6277,7 +6277,7 @@
             <a:r>
               <a:rPr sz="1900" b="1">
                 <a:solidFill>
-                  <a:srgbClr val="EEF0F4"/>
+                  <a:srgbClr val="EAF1FF"/>
                 </a:solidFill>
                 <a:latin typeface="Segoe UI"/>
               </a:rPr>
@@ -6316,7 +6316,7 @@
             <a:r>
               <a:rPr sz="1700" b="0">
                 <a:solidFill>
-                  <a:srgbClr val="9AA3B2"/>
+                  <a:srgbClr val="98A8D4"/>
                 </a:solidFill>
                 <a:latin typeface="Segoe UI"/>
               </a:rPr>
@@ -6398,7 +6398,7 @@
             <a:r>
               <a:rPr sz="1900" b="1">
                 <a:solidFill>
-                  <a:srgbClr val="EEF0F4"/>
+                  <a:srgbClr val="EAF1FF"/>
                 </a:solidFill>
                 <a:latin typeface="Segoe UI"/>
               </a:rPr>
@@ -6437,7 +6437,7 @@
             <a:r>
               <a:rPr sz="1700" b="0">
                 <a:solidFill>
-                  <a:srgbClr val="9AA3B2"/>
+                  <a:srgbClr val="98A8D4"/>
                 </a:solidFill>
                 <a:latin typeface="Segoe UI"/>
               </a:rPr>
@@ -6519,7 +6519,7 @@
             <a:r>
               <a:rPr sz="1900" b="1">
                 <a:solidFill>
-                  <a:srgbClr val="EEF0F4"/>
+                  <a:srgbClr val="EAF1FF"/>
                 </a:solidFill>
                 <a:latin typeface="Segoe UI"/>
               </a:rPr>
@@ -6558,7 +6558,7 @@
             <a:r>
               <a:rPr sz="1700" b="0">
                 <a:solidFill>
-                  <a:srgbClr val="9AA3B2"/>
+                  <a:srgbClr val="98A8D4"/>
                 </a:solidFill>
                 <a:latin typeface="Segoe UI"/>
               </a:rPr>
@@ -6640,7 +6640,7 @@
             <a:r>
               <a:rPr sz="1900" b="1">
                 <a:solidFill>
-                  <a:srgbClr val="EEF0F4"/>
+                  <a:srgbClr val="EAF1FF"/>
                 </a:solidFill>
                 <a:latin typeface="Segoe UI"/>
               </a:rPr>
@@ -6679,7 +6679,7 @@
             <a:r>
               <a:rPr sz="1700" b="0">
                 <a:solidFill>
-                  <a:srgbClr val="9AA3B2"/>
+                  <a:srgbClr val="98A8D4"/>
                 </a:solidFill>
                 <a:latin typeface="Segoe UI"/>
               </a:rPr>
@@ -6761,7 +6761,7 @@
             <a:r>
               <a:rPr sz="1900" b="1">
                 <a:solidFill>
-                  <a:srgbClr val="EEF0F4"/>
+                  <a:srgbClr val="EAF1FF"/>
                 </a:solidFill>
                 <a:latin typeface="Segoe UI"/>
               </a:rPr>
@@ -6800,7 +6800,7 @@
             <a:r>
               <a:rPr sz="1700" b="0">
                 <a:solidFill>
-                  <a:srgbClr val="9AA3B2"/>
+                  <a:srgbClr val="98A8D4"/>
                 </a:solidFill>
                 <a:latin typeface="Segoe UI"/>
               </a:rPr>
@@ -6823,7 +6823,7 @@
     <p:bg>
       <p:bgPr>
         <a:solidFill>
-          <a:srgbClr val="0F1115"/>
+          <a:srgbClr val="060A1A"/>
         </a:solidFill>
         <a:effectLst/>
       </p:bgPr>
@@ -6865,7 +6865,7 @@
             <a:r>
               <a:rPr sz="1300" b="1">
                 <a:solidFill>
-                  <a:srgbClr val="FF3B5C"/>
+                  <a:srgbClr val="3B82F6"/>
                 </a:solidFill>
                 <a:latin typeface="Segoe UI"/>
               </a:rPr>
@@ -6904,7 +6904,7 @@
             <a:r>
               <a:rPr sz="3400" b="1">
                 <a:solidFill>
-                  <a:srgbClr val="EEF0F4"/>
+                  <a:srgbClr val="EAF1FF"/>
                 </a:solidFill>
                 <a:latin typeface="Segoe UI"/>
               </a:rPr>
@@ -6930,11 +6930,11 @@
             </a:avLst>
           </a:prstGeom>
           <a:solidFill>
-            <a:srgbClr val="1A1E26"/>
+            <a:srgbClr val="111A3D"/>
           </a:solidFill>
           <a:ln>
             <a:solidFill>
-              <a:srgbClr val="2A2F3A"/>
+              <a:srgbClr val="243472"/>
             </a:solidFill>
           </a:ln>
         </p:spPr>
@@ -7033,7 +7033,7 @@
             <a:r>
               <a:rPr sz="2000" b="1">
                 <a:solidFill>
-                  <a:srgbClr val="EEF0F4"/>
+                  <a:srgbClr val="EAF1FF"/>
                 </a:solidFill>
                 <a:latin typeface="Segoe UI"/>
               </a:rPr>
@@ -7072,7 +7072,7 @@
             <a:r>
               <a:rPr sz="1500" b="0">
                 <a:solidFill>
-                  <a:srgbClr val="9AA3B2"/>
+                  <a:srgbClr val="98A8D4"/>
                 </a:solidFill>
                 <a:latin typeface="Segoe UI"/>
               </a:rPr>
@@ -7098,11 +7098,11 @@
             </a:avLst>
           </a:prstGeom>
           <a:solidFill>
-            <a:srgbClr val="1A1E26"/>
+            <a:srgbClr val="111A3D"/>
           </a:solidFill>
           <a:ln>
             <a:solidFill>
-              <a:srgbClr val="2A2F3A"/>
+              <a:srgbClr val="243472"/>
             </a:solidFill>
           </a:ln>
         </p:spPr>
@@ -7201,7 +7201,7 @@
             <a:r>
               <a:rPr sz="2000" b="1">
                 <a:solidFill>
-                  <a:srgbClr val="EEF0F4"/>
+                  <a:srgbClr val="EAF1FF"/>
                 </a:solidFill>
                 <a:latin typeface="Segoe UI"/>
               </a:rPr>
@@ -7240,7 +7240,7 @@
             <a:r>
               <a:rPr sz="1500" b="0">
                 <a:solidFill>
-                  <a:srgbClr val="9AA3B2"/>
+                  <a:srgbClr val="98A8D4"/>
                 </a:solidFill>
                 <a:latin typeface="Segoe UI"/>
               </a:rPr>
@@ -7266,11 +7266,11 @@
             </a:avLst>
           </a:prstGeom>
           <a:solidFill>
-            <a:srgbClr val="1A1E26"/>
+            <a:srgbClr val="111A3D"/>
           </a:solidFill>
           <a:ln>
             <a:solidFill>
-              <a:srgbClr val="2A2F3A"/>
+              <a:srgbClr val="243472"/>
             </a:solidFill>
           </a:ln>
         </p:spPr>
@@ -7369,7 +7369,7 @@
             <a:r>
               <a:rPr sz="2000" b="1">
                 <a:solidFill>
-                  <a:srgbClr val="EEF0F4"/>
+                  <a:srgbClr val="EAF1FF"/>
                 </a:solidFill>
                 <a:latin typeface="Segoe UI"/>
               </a:rPr>
@@ -7408,7 +7408,7 @@
             <a:r>
               <a:rPr sz="1500" b="0">
                 <a:solidFill>
-                  <a:srgbClr val="9AA3B2"/>
+                  <a:srgbClr val="98A8D4"/>
                 </a:solidFill>
                 <a:latin typeface="Segoe UI"/>
               </a:rPr>
@@ -7431,7 +7431,7 @@
     <p:bg>
       <p:bgPr>
         <a:solidFill>
-          <a:srgbClr val="0F1115"/>
+          <a:srgbClr val="060A1A"/>
         </a:solidFill>
         <a:effectLst/>
       </p:bgPr>
@@ -7497,7 +7497,7 @@
             <a:r>
               <a:rPr sz="3200" b="1">
                 <a:solidFill>
-                  <a:srgbClr val="EEF0F4"/>
+                  <a:srgbClr val="EAF1FF"/>
                 </a:solidFill>
                 <a:latin typeface="Segoe UI"/>
               </a:rPr>
@@ -7536,7 +7536,7 @@
             <a:r>
               <a:rPr sz="1800" b="0">
                 <a:solidFill>
-                  <a:srgbClr val="9AA3B2"/>
+                  <a:srgbClr val="98A8D4"/>
                 </a:solidFill>
                 <a:latin typeface="Segoe UI"/>
               </a:rPr>
@@ -7552,7 +7552,7 @@
             <a:r>
               <a:rPr sz="1800" b="0">
                 <a:solidFill>
-                  <a:srgbClr val="9AA3B2"/>
+                  <a:srgbClr val="98A8D4"/>
                 </a:solidFill>
                 <a:latin typeface="Segoe UI"/>
               </a:rPr>

</xml_diff>